<commit_message>
Re-enable HTML emails with Resend tracking disabled for Primary tab
Disabling open/click tracking on tastelanc.com via Resend API prevents
tracking markup injection into HTML. Clean HTML with <p>, <strong>, and
styled signature now confirmed to land in Gmail Primary tab.

- Re-enable html field in both send routes (inbox + lead email)
- Update template: bold sender name, title+brand sig, no links/images
- Remove <a>, <img>, <ul> elements (trigger Promotions)
- Remove unused ctaText/ctaUrl/headline params from render functions
- Add sales rep sender identity enforcement to inbox route

Co-Authored-By: Claude Opus 4.6 <noreply@anthropic.com>
</commit_message>
<xml_diff>
--- a/pitchdeck/TasteLanc_PitchDeck.pptx
+++ b/pitchdeck/TasteLanc_PitchDeck.pptx
@@ -3125,8 +3125,8 @@
         </p:blipFill>
         <p:spPr>
           <a:xfrm>
-            <a:off x="3840480" y="914400"/>
-            <a:ext cx="4572000" cy="4572000"/>
+            <a:off x="4952847" y="548640"/>
+            <a:ext cx="2286000" cy="2286000"/>
           </a:xfrm>
           <a:prstGeom prst="rect">
             <a:avLst/>
@@ -3141,7 +3141,7 @@
         </p:nvSpPr>
         <p:spPr>
           <a:xfrm>
-            <a:off x="4937760" y="3474720"/>
+            <a:off x="4937760" y="3200400"/>
             <a:ext cx="2286000" cy="50800"/>
           </a:xfrm>
           <a:prstGeom prst="rect">
@@ -3184,7 +3184,7 @@
         </p:nvSpPr>
         <p:spPr>
           <a:xfrm>
-            <a:off x="1828800" y="3840480"/>
+            <a:off x="1828800" y="3566160"/>
             <a:ext cx="8229600" cy="731520"/>
           </a:xfrm>
           <a:prstGeom prst="rect">
@@ -3199,7 +3199,7 @@
           <a:lstStyle/>
           <a:p>
             <a:pPr algn="ctr">
-              <a:defRPr sz="3600" b="1">
+              <a:defRPr sz="4000" b="1">
                 <a:solidFill>
                   <a:srgbClr val="FFFFFF"/>
                 </a:solidFill>
@@ -3220,7 +3220,7 @@
         </p:nvSpPr>
         <p:spPr>
           <a:xfrm>
-            <a:off x="1828800" y="4754880"/>
+            <a:off x="1828800" y="4480560"/>
             <a:ext cx="8229600" cy="548640"/>
           </a:xfrm>
           <a:prstGeom prst="rect">
@@ -3235,7 +3235,7 @@
           <a:lstStyle/>
           <a:p>
             <a:pPr algn="ctr">
-              <a:defRPr sz="2000" b="0">
+              <a:defRPr sz="2200" b="0">
                 <a:solidFill>
                   <a:srgbClr val="999999"/>
                 </a:solidFill>
@@ -6657,8 +6657,8 @@
         </p:blipFill>
         <p:spPr>
           <a:xfrm>
-            <a:off x="3840480" y="731520"/>
-            <a:ext cx="4572000" cy="4572000"/>
+            <a:off x="5181447" y="457200"/>
+            <a:ext cx="1828800" cy="1828800"/>
           </a:xfrm>
           <a:prstGeom prst="rect">
             <a:avLst/>
@@ -6673,7 +6673,7 @@
         </p:nvSpPr>
         <p:spPr>
           <a:xfrm>
-            <a:off x="4937760" y="2743200"/>
+            <a:off x="4937760" y="2560320"/>
             <a:ext cx="2286000" cy="50800"/>
           </a:xfrm>
           <a:prstGeom prst="rect">
@@ -6716,7 +6716,7 @@
         </p:nvSpPr>
         <p:spPr>
           <a:xfrm>
-            <a:off x="1371600" y="3108960"/>
+            <a:off x="1371600" y="2926080"/>
             <a:ext cx="9144000" cy="731520"/>
           </a:xfrm>
           <a:prstGeom prst="rect">
@@ -6756,7 +6756,7 @@
         </p:nvSpPr>
         <p:spPr>
           <a:xfrm>
-            <a:off x="2743200" y="4206240"/>
+            <a:off x="2743200" y="4023360"/>
             <a:ext cx="6400800" cy="1371600"/>
           </a:xfrm>
           <a:prstGeom prst="rect">
@@ -6827,7 +6827,7 @@
         </p:nvSpPr>
         <p:spPr>
           <a:xfrm>
-            <a:off x="1828800" y="5760720"/>
+            <a:off x="1828800" y="5669280"/>
             <a:ext cx="8229600" cy="274320"/>
           </a:xfrm>
           <a:prstGeom prst="rect">
@@ -6863,7 +6863,7 @@
         </p:nvSpPr>
         <p:spPr>
           <a:xfrm>
-            <a:off x="1828800" y="6217920"/>
+            <a:off x="1828800" y="6126480"/>
             <a:ext cx="8229600" cy="274320"/>
           </a:xfrm>
           <a:prstGeom prst="rect">
@@ -9000,7 +9000,7 @@
       </p:sp>
       <p:pic>
         <p:nvPicPr>
-          <p:cNvPr id="5" name="Picture 4" descr="6.5_01_home.png"/>
+          <p:cNvPr id="5" name="Picture 4" descr="framed_6.5_01_home.png"/>
           <p:cNvPicPr>
             <a:picLocks noChangeAspect="1"/>
           </p:cNvPicPr>
@@ -9014,8 +9014,8 @@
         </p:blipFill>
         <p:spPr>
           <a:xfrm>
-            <a:off x="457200" y="2011680"/>
-            <a:ext cx="1901258" cy="4114800"/>
+            <a:off x="457200" y="1920240"/>
+            <a:ext cx="1966630" cy="4206240"/>
           </a:xfrm>
           <a:prstGeom prst="rect">
             <a:avLst/>
@@ -9030,8 +9030,8 @@
         </p:nvSpPr>
         <p:spPr>
           <a:xfrm>
-            <a:off x="457200" y="6172200"/>
-            <a:ext cx="1737360" cy="274320"/>
+            <a:off x="457200" y="6217920"/>
+            <a:ext cx="1828800" cy="274320"/>
           </a:xfrm>
           <a:prstGeom prst="rect">
             <a:avLst/>
@@ -9045,7 +9045,7 @@
           <a:lstStyle/>
           <a:p>
             <a:pPr algn="ctr">
-              <a:defRPr sz="1100" b="0">
+              <a:defRPr sz="1200" b="0">
                 <a:solidFill>
                   <a:srgbClr val="999999"/>
                 </a:solidFill>
@@ -9060,7 +9060,7 @@
       </p:sp>
       <p:pic>
         <p:nvPicPr>
-          <p:cNvPr id="7" name="Picture 6" descr="6.5_02_search.png"/>
+          <p:cNvPr id="7" name="Picture 6" descr="framed_6.5_02_search.png"/>
           <p:cNvPicPr>
             <a:picLocks noChangeAspect="1"/>
           </p:cNvPicPr>
@@ -9074,8 +9074,8 @@
         </p:blipFill>
         <p:spPr>
           <a:xfrm>
-            <a:off x="2377440" y="2011680"/>
-            <a:ext cx="1901258" cy="4114800"/>
+            <a:off x="2346899" y="1920240"/>
+            <a:ext cx="1966630" cy="4206240"/>
           </a:xfrm>
           <a:prstGeom prst="rect">
             <a:avLst/>
@@ -9090,8 +9090,8 @@
         </p:nvSpPr>
         <p:spPr>
           <a:xfrm>
-            <a:off x="2377440" y="6172200"/>
-            <a:ext cx="1737360" cy="274320"/>
+            <a:off x="2346899" y="6217920"/>
+            <a:ext cx="1828800" cy="274320"/>
           </a:xfrm>
           <a:prstGeom prst="rect">
             <a:avLst/>
@@ -9105,7 +9105,7 @@
           <a:lstStyle/>
           <a:p>
             <a:pPr algn="ctr">
-              <a:defRPr sz="1100" b="0">
+              <a:defRPr sz="1200" b="0">
                 <a:solidFill>
                   <a:srgbClr val="999999"/>
                 </a:solidFill>
@@ -9120,7 +9120,7 @@
       </p:sp>
       <p:pic>
         <p:nvPicPr>
-          <p:cNvPr id="9" name="Picture 8" descr="6.5_03_rosie_ai.png"/>
+          <p:cNvPr id="9" name="Picture 8" descr="framed_6.5_03_rosie_ai.png"/>
           <p:cNvPicPr>
             <a:picLocks noChangeAspect="1"/>
           </p:cNvPicPr>
@@ -9134,8 +9134,8 @@
         </p:blipFill>
         <p:spPr>
           <a:xfrm>
-            <a:off x="4297680" y="2011680"/>
-            <a:ext cx="1901258" cy="4114800"/>
+            <a:off x="4236598" y="1920240"/>
+            <a:ext cx="1966630" cy="4206240"/>
           </a:xfrm>
           <a:prstGeom prst="rect">
             <a:avLst/>
@@ -9150,8 +9150,8 @@
         </p:nvSpPr>
         <p:spPr>
           <a:xfrm>
-            <a:off x="4297680" y="6172200"/>
-            <a:ext cx="1737360" cy="274320"/>
+            <a:off x="4236598" y="6217920"/>
+            <a:ext cx="1828800" cy="274320"/>
           </a:xfrm>
           <a:prstGeom prst="rect">
             <a:avLst/>
@@ -9165,7 +9165,7 @@
           <a:lstStyle/>
           <a:p>
             <a:pPr algn="ctr">
-              <a:defRPr sz="1100" b="0">
+              <a:defRPr sz="1200" b="0">
                 <a:solidFill>
                   <a:srgbClr val="999999"/>
                 </a:solidFill>
@@ -9180,7 +9180,7 @@
       </p:sp>
       <p:pic>
         <p:nvPicPr>
-          <p:cNvPr id="11" name="Picture 10" descr="6.5_04_happy_hours.png"/>
+          <p:cNvPr id="11" name="Picture 10" descr="framed_6.5_04_happy_hours.png"/>
           <p:cNvPicPr>
             <a:picLocks noChangeAspect="1"/>
           </p:cNvPicPr>
@@ -9194,8 +9194,8 @@
         </p:blipFill>
         <p:spPr>
           <a:xfrm>
-            <a:off x="6217920" y="2011680"/>
-            <a:ext cx="1901258" cy="4114800"/>
+            <a:off x="6126297" y="1920240"/>
+            <a:ext cx="1966630" cy="4206240"/>
           </a:xfrm>
           <a:prstGeom prst="rect">
             <a:avLst/>
@@ -9210,8 +9210,8 @@
         </p:nvSpPr>
         <p:spPr>
           <a:xfrm>
-            <a:off x="6217920" y="6172200"/>
-            <a:ext cx="1737360" cy="274320"/>
+            <a:off x="6126297" y="6217920"/>
+            <a:ext cx="1828800" cy="274320"/>
           </a:xfrm>
           <a:prstGeom prst="rect">
             <a:avLst/>
@@ -9225,7 +9225,7 @@
           <a:lstStyle/>
           <a:p>
             <a:pPr algn="ctr">
-              <a:defRPr sz="1100" b="0">
+              <a:defRPr sz="1200" b="0">
                 <a:solidFill>
                   <a:srgbClr val="999999"/>
                 </a:solidFill>
@@ -9240,7 +9240,7 @@
       </p:sp>
       <p:pic>
         <p:nvPicPr>
-          <p:cNvPr id="13" name="Picture 12" descr="6.5_05_detail.png"/>
+          <p:cNvPr id="13" name="Picture 12" descr="framed_6.5_05_detail.png"/>
           <p:cNvPicPr>
             <a:picLocks noChangeAspect="1"/>
           </p:cNvPicPr>
@@ -9254,8 +9254,8 @@
         </p:blipFill>
         <p:spPr>
           <a:xfrm>
-            <a:off x="8138160" y="2011680"/>
-            <a:ext cx="1901258" cy="4114800"/>
+            <a:off x="8015996" y="1920240"/>
+            <a:ext cx="1966630" cy="4206240"/>
           </a:xfrm>
           <a:prstGeom prst="rect">
             <a:avLst/>
@@ -9270,8 +9270,8 @@
         </p:nvSpPr>
         <p:spPr>
           <a:xfrm>
-            <a:off x="8138160" y="6172200"/>
-            <a:ext cx="1737360" cy="274320"/>
+            <a:off x="8015996" y="6217920"/>
+            <a:ext cx="1828800" cy="274320"/>
           </a:xfrm>
           <a:prstGeom prst="rect">
             <a:avLst/>
@@ -9285,7 +9285,7 @@
           <a:lstStyle/>
           <a:p>
             <a:pPr algn="ctr">
-              <a:defRPr sz="1100" b="0">
+              <a:defRPr sz="1200" b="0">
                 <a:solidFill>
                   <a:srgbClr val="999999"/>
                 </a:solidFill>
@@ -9300,7 +9300,7 @@
       </p:sp>
       <p:pic>
         <p:nvPicPr>
-          <p:cNvPr id="15" name="Picture 14" descr="6.5_06_voting.png"/>
+          <p:cNvPr id="15" name="Picture 14" descr="framed_6.5_06_voting.png"/>
           <p:cNvPicPr>
             <a:picLocks noChangeAspect="1"/>
           </p:cNvPicPr>
@@ -9314,8 +9314,8 @@
         </p:blipFill>
         <p:spPr>
           <a:xfrm>
-            <a:off x="10058400" y="2011680"/>
-            <a:ext cx="1901258" cy="4114800"/>
+            <a:off x="9905695" y="1920240"/>
+            <a:ext cx="1966630" cy="4206240"/>
           </a:xfrm>
           <a:prstGeom prst="rect">
             <a:avLst/>
@@ -9330,8 +9330,8 @@
         </p:nvSpPr>
         <p:spPr>
           <a:xfrm>
-            <a:off x="10058400" y="6172200"/>
-            <a:ext cx="1737360" cy="274320"/>
+            <a:off x="9905695" y="6217920"/>
+            <a:ext cx="1828800" cy="274320"/>
           </a:xfrm>
           <a:prstGeom prst="rect">
             <a:avLst/>
@@ -9345,7 +9345,7 @@
           <a:lstStyle/>
           <a:p>
             <a:pPr algn="ctr">
-              <a:defRPr sz="1100" b="0">
+              <a:defRPr sz="1200" b="0">
                 <a:solidFill>
                   <a:srgbClr val="999999"/>
                 </a:solidFill>

</xml_diff>